<commit_message>
Add lecture 12 PPT (예기치 않은 죽음·재난·사고와 애도교육); wrap-safe cover title
Co-Authored-By: Claude Opus 5.5 <noreply@anthropic.com>
Claude-Session: https://claude.ai/code/session_011L3sm83vPfAuzHdbV1bgYe
</commit_message>
<xml_diff>
--- a/ppt/out/WLC2급_제09강_존엄한의료결정·사전돌봄계획과후견.pptx
+++ b/ppt/out/WLC2급_제09강_존엄한의료결정·사전돌봄계획과후견.pptx
@@ -158,7 +158,7 @@
   <p:extLst>
     <p:ext uri="{521415D9-36F7-43E2-AB2F-B90AF26B5E84}">
       <p14:sectionLst xmlns:p14="http://schemas.microsoft.com/office/powerpoint/2010/main">
-        <p14:section name="열기" id="{580e3aac-ef22-7754-1862-772d8313d9a4}">
+        <p14:section name="열기" id="{e2814e01-3bf6-0fb1-034e-936f55c4c2dc}">
           <p14:sldIdLst>
             <p14:sldId id="256"/>
             <p14:sldId id="257"/>
@@ -171,7 +171,7 @@
             <p14:sldId id="264"/>
           </p14:sldIdLst>
         </p14:section>
-        <p14:section name="1교시 연명의료결정제도의 언어" id="{c4d67f99-3323-89dc-6aab-58747b03d362}">
+        <p14:section name="1교시 연명의료결정제도의 언어" id="{3effc509-e2ad-926d-5264-c7bd218069d4}">
           <p14:sldIdLst>
             <p14:sldId id="265"/>
             <p14:sldId id="266"/>
@@ -184,7 +184,7 @@
             <p14:sldId id="273"/>
           </p14:sldIdLst>
         </p14:section>
-        <p14:section name="2교시 ACP·호스피스·후견" id="{c4a1b806-2f98-3f48-5e3b-4f5b32897a56}">
+        <p14:section name="2교시 ACP·호스피스·후견" id="{5ca036e0-a364-a30b-7bbe-a4590891337c}">
           <p14:sldIdLst>
             <p14:sldId id="274"/>
             <p14:sldId id="275"/>
@@ -200,7 +200,7 @@
             <p14:sldId id="285"/>
           </p14:sldIdLst>
         </p14:section>
-        <p14:section name="3교시 나의 의료·돌봄 가치 설계" id="{d0118a3c-25a8-9015-95c8-5d871cc18b41}">
+        <p14:section name="3교시 나의 의료·돌봄 가치 설계" id="{14890d17-c75e-d56d-2d6f-4cbae7fa39de}">
           <p14:sldIdLst>
             <p14:sldId id="286"/>
             <p14:sldId id="287"/>
@@ -220,7 +220,7 @@
             <p14:sldId id="301"/>
           </p14:sldIdLst>
         </p14:section>
-        <p14:section name="정리와 예고" id="{04b9467d-4b97-dcbe-4d0b-4690583d0db7}">
+        <p14:section name="정리와 예고" id="{4e31f919-9984-2f25-503e-cdaf2e5e4aa8}">
           <p14:sldIdLst>
             <p14:sldId id="302"/>
             <p14:sldId id="303"/>
@@ -6382,8 +6382,8 @@
         </p:nvSpPr>
         <p:spPr>
           <a:xfrm>
-            <a:off x="548640" y="2560320"/>
-            <a:ext cx="9144000" cy="1097280"/>
+            <a:off x="548640" y="2514600"/>
+            <a:ext cx="10607040" cy="1828800"/>
           </a:xfrm>
           <a:prstGeom prst="rect">
             <a:avLst/>
@@ -6421,7 +6421,7 @@
         </p:nvSpPr>
         <p:spPr>
           <a:xfrm>
-            <a:off x="548640" y="3703320"/>
+            <a:off x="548640" y="4434840"/>
             <a:ext cx="8229600" cy="411480"/>
           </a:xfrm>
           <a:prstGeom prst="rect">
@@ -6457,7 +6457,7 @@
         </p:nvSpPr>
         <p:spPr>
           <a:xfrm>
-            <a:off x="548640" y="5120640"/>
+            <a:off x="548640" y="4983480"/>
             <a:ext cx="8229600" cy="365760"/>
           </a:xfrm>
           <a:prstGeom prst="rect">

</xml_diff>